<commit_message>
native editable bright agent pptx
</commit_message>
<xml_diff>
--- a/bright-01-just-listed.pptx
+++ b/bright-01-just-listed.pptx
@@ -3088,20 +3088,12 @@
         <p:nvPr/>
       </p:nvGrpSpPr>
       <p:grpSpPr/>
-      <p:pic>
-        <p:nvPicPr>
-          <p:cNvPr id="2" name="Picture 1" descr="bright-01-just-listed.png"/>
-          <p:cNvPicPr>
-            <a:picLocks noChangeAspect="1"/>
-          </p:cNvPicPr>
+      <p:sp>
+        <p:nvSpPr>
+          <p:cNvPr id="2" name="Rectangle 1"/>
+          <p:cNvSpPr/>
           <p:nvPr/>
-        </p:nvPicPr>
-        <p:blipFill>
-          <a:blip r:embed="rId2"/>
-          <a:stretch>
-            <a:fillRect/>
-          </a:stretch>
-        </p:blipFill>
+        </p:nvSpPr>
         <p:spPr>
           <a:xfrm>
             <a:off x="0" y="0"/>
@@ -3110,8 +3102,986 @@
           <a:prstGeom prst="rect">
             <a:avLst/>
           </a:prstGeom>
-        </p:spPr>
-      </p:pic>
+          <a:solidFill>
+            <a:srgbClr val="FBFAF7"/>
+          </a:solidFill>
+          <a:ln>
+            <a:noFill/>
+          </a:ln>
+          <a:effectLst/>
+        </p:spPr>
+        <p:style>
+          <a:lnRef idx="1">
+            <a:schemeClr val="accent1"/>
+          </a:lnRef>
+          <a:fillRef idx="3">
+            <a:schemeClr val="accent1"/>
+          </a:fillRef>
+          <a:effectRef idx="2">
+            <a:schemeClr val="accent1"/>
+          </a:effectRef>
+          <a:fontRef idx="minor">
+            <a:schemeClr val="lt1"/>
+          </a:fontRef>
+        </p:style>
+        <p:txBody>
+          <a:bodyPr rtlCol="0" anchor="ctr"/>
+          <a:lstStyle/>
+          <a:p>
+            <a:pPr algn="ctr"/>
+          </a:p>
+        </p:txBody>
+      </p:sp>
+      <p:sp>
+        <p:nvSpPr>
+          <p:cNvPr id="3" name="Rectangle 2"/>
+          <p:cNvSpPr/>
+          <p:nvPr/>
+        </p:nvSpPr>
+        <p:spPr>
+          <a:xfrm>
+            <a:off x="762000" y="1409700"/>
+            <a:ext cx="8763000" cy="9525"/>
+          </a:xfrm>
+          <a:prstGeom prst="rect">
+            <a:avLst/>
+          </a:prstGeom>
+          <a:solidFill>
+            <a:srgbClr val="C4CDBC"/>
+          </a:solidFill>
+          <a:ln>
+            <a:noFill/>
+          </a:ln>
+          <a:effectLst/>
+        </p:spPr>
+        <p:style>
+          <a:lnRef idx="1">
+            <a:schemeClr val="accent1"/>
+          </a:lnRef>
+          <a:fillRef idx="3">
+            <a:schemeClr val="accent1"/>
+          </a:fillRef>
+          <a:effectRef idx="2">
+            <a:schemeClr val="accent1"/>
+          </a:effectRef>
+          <a:fontRef idx="minor">
+            <a:schemeClr val="lt1"/>
+          </a:fontRef>
+        </p:style>
+        <p:txBody>
+          <a:bodyPr rtlCol="0" anchor="ctr"/>
+          <a:lstStyle/>
+          <a:p>
+            <a:pPr algn="ctr"/>
+          </a:p>
+        </p:txBody>
+      </p:sp>
+      <p:sp>
+        <p:nvSpPr>
+          <p:cNvPr id="4" name="Oval 3"/>
+          <p:cNvSpPr/>
+          <p:nvPr/>
+        </p:nvSpPr>
+        <p:spPr>
+          <a:xfrm>
+            <a:off x="762000" y="771525"/>
+            <a:ext cx="381000" cy="381000"/>
+          </a:xfrm>
+          <a:prstGeom prst="ellipse">
+            <a:avLst/>
+          </a:prstGeom>
+          <a:noFill/>
+          <a:ln w="9525">
+            <a:solidFill>
+              <a:srgbClr val="97A98C"/>
+            </a:solidFill>
+          </a:ln>
+          <a:effectLst/>
+        </p:spPr>
+        <p:style>
+          <a:lnRef idx="1">
+            <a:schemeClr val="accent1"/>
+          </a:lnRef>
+          <a:fillRef idx="3">
+            <a:schemeClr val="accent1"/>
+          </a:fillRef>
+          <a:effectRef idx="2">
+            <a:schemeClr val="accent1"/>
+          </a:effectRef>
+          <a:fontRef idx="minor">
+            <a:schemeClr val="lt1"/>
+          </a:fontRef>
+        </p:style>
+        <p:txBody>
+          <a:bodyPr rtlCol="0" anchor="ctr"/>
+          <a:lstStyle/>
+          <a:p>
+            <a:pPr algn="ctr"/>
+          </a:p>
+        </p:txBody>
+      </p:sp>
+      <p:sp>
+        <p:nvSpPr>
+          <p:cNvPr id="5" name="Rectangle 4"/>
+          <p:cNvSpPr/>
+          <p:nvPr/>
+        </p:nvSpPr>
+        <p:spPr>
+          <a:xfrm>
+            <a:off x="3653284" y="2171700"/>
+            <a:ext cx="666750" cy="9525"/>
+          </a:xfrm>
+          <a:prstGeom prst="rect">
+            <a:avLst/>
+          </a:prstGeom>
+          <a:solidFill>
+            <a:srgbClr val="97A98C"/>
+          </a:solidFill>
+          <a:ln>
+            <a:noFill/>
+          </a:ln>
+          <a:effectLst/>
+        </p:spPr>
+        <p:style>
+          <a:lnRef idx="1">
+            <a:schemeClr val="accent1"/>
+          </a:lnRef>
+          <a:fillRef idx="3">
+            <a:schemeClr val="accent1"/>
+          </a:fillRef>
+          <a:effectRef idx="2">
+            <a:schemeClr val="accent1"/>
+          </a:effectRef>
+          <a:fontRef idx="minor">
+            <a:schemeClr val="lt1"/>
+          </a:fontRef>
+        </p:style>
+        <p:txBody>
+          <a:bodyPr rtlCol="0" anchor="ctr"/>
+          <a:lstStyle/>
+          <a:p>
+            <a:pPr algn="ctr"/>
+          </a:p>
+        </p:txBody>
+      </p:sp>
+      <p:sp>
+        <p:nvSpPr>
+          <p:cNvPr id="6" name="Rectangle 5"/>
+          <p:cNvSpPr/>
+          <p:nvPr/>
+        </p:nvSpPr>
+        <p:spPr>
+          <a:xfrm>
+            <a:off x="5966817" y="2171700"/>
+            <a:ext cx="666750" cy="9525"/>
+          </a:xfrm>
+          <a:prstGeom prst="rect">
+            <a:avLst/>
+          </a:prstGeom>
+          <a:solidFill>
+            <a:srgbClr val="97A98C"/>
+          </a:solidFill>
+          <a:ln>
+            <a:noFill/>
+          </a:ln>
+          <a:effectLst/>
+        </p:spPr>
+        <p:style>
+          <a:lnRef idx="1">
+            <a:schemeClr val="accent1"/>
+          </a:lnRef>
+          <a:fillRef idx="3">
+            <a:schemeClr val="accent1"/>
+          </a:fillRef>
+          <a:effectRef idx="2">
+            <a:schemeClr val="accent1"/>
+          </a:effectRef>
+          <a:fontRef idx="minor">
+            <a:schemeClr val="lt1"/>
+          </a:fontRef>
+        </p:style>
+        <p:txBody>
+          <a:bodyPr rtlCol="0" anchor="ctr"/>
+          <a:lstStyle/>
+          <a:p>
+            <a:pPr algn="ctr"/>
+          </a:p>
+        </p:txBody>
+      </p:sp>
+      <p:sp>
+        <p:nvSpPr>
+          <p:cNvPr id="7" name="Rectangle 6"/>
+          <p:cNvSpPr/>
+          <p:nvPr/>
+        </p:nvSpPr>
+        <p:spPr>
+          <a:xfrm>
+            <a:off x="3930551" y="6450806"/>
+            <a:ext cx="9525" cy="752475"/>
+          </a:xfrm>
+          <a:prstGeom prst="rect">
+            <a:avLst/>
+          </a:prstGeom>
+          <a:solidFill>
+            <a:srgbClr val="CED6C7"/>
+          </a:solidFill>
+          <a:ln>
+            <a:noFill/>
+          </a:ln>
+          <a:effectLst/>
+        </p:spPr>
+        <p:style>
+          <a:lnRef idx="1">
+            <a:schemeClr val="accent1"/>
+          </a:lnRef>
+          <a:fillRef idx="3">
+            <a:schemeClr val="accent1"/>
+          </a:fillRef>
+          <a:effectRef idx="2">
+            <a:schemeClr val="accent1"/>
+          </a:effectRef>
+          <a:fontRef idx="minor">
+            <a:schemeClr val="lt1"/>
+          </a:fontRef>
+        </p:style>
+        <p:txBody>
+          <a:bodyPr rtlCol="0" anchor="ctr"/>
+          <a:lstStyle/>
+          <a:p>
+            <a:pPr algn="ctr"/>
+          </a:p>
+        </p:txBody>
+      </p:sp>
+      <p:sp>
+        <p:nvSpPr>
+          <p:cNvPr id="8" name="Rectangle 7"/>
+          <p:cNvSpPr/>
+          <p:nvPr/>
+        </p:nvSpPr>
+        <p:spPr>
+          <a:xfrm>
+            <a:off x="6346775" y="6450806"/>
+            <a:ext cx="9525" cy="752475"/>
+          </a:xfrm>
+          <a:prstGeom prst="rect">
+            <a:avLst/>
+          </a:prstGeom>
+          <a:solidFill>
+            <a:srgbClr val="CED6C7"/>
+          </a:solidFill>
+          <a:ln>
+            <a:noFill/>
+          </a:ln>
+          <a:effectLst/>
+        </p:spPr>
+        <p:style>
+          <a:lnRef idx="1">
+            <a:schemeClr val="accent1"/>
+          </a:lnRef>
+          <a:fillRef idx="3">
+            <a:schemeClr val="accent1"/>
+          </a:fillRef>
+          <a:effectRef idx="2">
+            <a:schemeClr val="accent1"/>
+          </a:effectRef>
+          <a:fontRef idx="minor">
+            <a:schemeClr val="lt1"/>
+          </a:fontRef>
+        </p:style>
+        <p:txBody>
+          <a:bodyPr rtlCol="0" anchor="ctr"/>
+          <a:lstStyle/>
+          <a:p>
+            <a:pPr algn="ctr"/>
+          </a:p>
+        </p:txBody>
+      </p:sp>
+      <p:sp>
+        <p:nvSpPr>
+          <p:cNvPr id="9" name="Rectangle 8"/>
+          <p:cNvSpPr/>
+          <p:nvPr/>
+        </p:nvSpPr>
+        <p:spPr>
+          <a:xfrm>
+            <a:off x="762000" y="9134475"/>
+            <a:ext cx="8763000" cy="9525"/>
+          </a:xfrm>
+          <a:prstGeom prst="rect">
+            <a:avLst/>
+          </a:prstGeom>
+          <a:solidFill>
+            <a:srgbClr val="C4CDBC"/>
+          </a:solidFill>
+          <a:ln>
+            <a:noFill/>
+          </a:ln>
+          <a:effectLst/>
+        </p:spPr>
+        <p:style>
+          <a:lnRef idx="1">
+            <a:schemeClr val="accent1"/>
+          </a:lnRef>
+          <a:fillRef idx="3">
+            <a:schemeClr val="accent1"/>
+          </a:fillRef>
+          <a:effectRef idx="2">
+            <a:schemeClr val="accent1"/>
+          </a:effectRef>
+          <a:fontRef idx="minor">
+            <a:schemeClr val="lt1"/>
+          </a:fontRef>
+        </p:style>
+        <p:txBody>
+          <a:bodyPr rtlCol="0" anchor="ctr"/>
+          <a:lstStyle/>
+          <a:p>
+            <a:pPr algn="ctr"/>
+          </a:p>
+        </p:txBody>
+      </p:sp>
+      <p:sp>
+        <p:nvSpPr>
+          <p:cNvPr id="10" name="Oval 9"/>
+          <p:cNvSpPr/>
+          <p:nvPr/>
+        </p:nvSpPr>
+        <p:spPr>
+          <a:xfrm>
+            <a:off x="762000" y="9415462"/>
+            <a:ext cx="66675" cy="66675"/>
+          </a:xfrm>
+          <a:prstGeom prst="ellipse">
+            <a:avLst/>
+          </a:prstGeom>
+          <a:solidFill>
+            <a:srgbClr val="E6D2CB"/>
+          </a:solidFill>
+          <a:ln>
+            <a:noFill/>
+          </a:ln>
+          <a:effectLst/>
+        </p:spPr>
+        <p:style>
+          <a:lnRef idx="1">
+            <a:schemeClr val="accent1"/>
+          </a:lnRef>
+          <a:fillRef idx="3">
+            <a:schemeClr val="accent1"/>
+          </a:fillRef>
+          <a:effectRef idx="2">
+            <a:schemeClr val="accent1"/>
+          </a:effectRef>
+          <a:fontRef idx="minor">
+            <a:schemeClr val="lt1"/>
+          </a:fontRef>
+        </p:style>
+        <p:txBody>
+          <a:bodyPr rtlCol="0" anchor="ctr"/>
+          <a:lstStyle/>
+          <a:p>
+            <a:pPr algn="ctr"/>
+          </a:p>
+        </p:txBody>
+      </p:sp>
+      <p:sp>
+        <p:nvSpPr>
+          <p:cNvPr id="11" name="TextBox 10"/>
+          <p:cNvSpPr txBox="1"/>
+          <p:nvPr/>
+        </p:nvSpPr>
+        <p:spPr>
+          <a:xfrm>
+            <a:off x="820341" y="876300"/>
+            <a:ext cx="803672" cy="171450"/>
+          </a:xfrm>
+          <a:prstGeom prst="rect">
+            <a:avLst/>
+          </a:prstGeom>
+          <a:noFill/>
+        </p:spPr>
+        <p:txBody>
+          <a:bodyPr wrap="none" anchor="t" lIns="0" rIns="0" tIns="0" bIns="0"/>
+          <a:lstStyle/>
+          <a:p>
+            <a:pPr algn="l">
+              <a:lnSpc>
+                <a:spcPct val="100000"/>
+              </a:lnSpc>
+            </a:pPr>
+            <a:r>
+              <a:rPr sz="1350" i="0" b="0" spc="27">
+                <a:solidFill>
+                  <a:srgbClr val="97A98C"/>
+                </a:solidFill>
+                <a:latin typeface="Cormorant Garamond"/>
+                <a:ea typeface="Cormorant Garamond"/>
+                <a:cs typeface="Cormorant Garamond"/>
+              </a:rPr>
+              <a:t>ME</a:t>
+            </a:r>
+          </a:p>
+        </p:txBody>
+      </p:sp>
+      <p:sp>
+        <p:nvSpPr>
+          <p:cNvPr id="12" name="TextBox 11"/>
+          <p:cNvSpPr txBox="1"/>
+          <p:nvPr/>
+        </p:nvSpPr>
+        <p:spPr>
+          <a:xfrm>
+            <a:off x="1295400" y="762000"/>
+            <a:ext cx="3282315" cy="228600"/>
+          </a:xfrm>
+          <a:prstGeom prst="rect">
+            <a:avLst/>
+          </a:prstGeom>
+          <a:noFill/>
+        </p:spPr>
+        <p:txBody>
+          <a:bodyPr wrap="none" anchor="t" lIns="0" rIns="0" tIns="0" bIns="0"/>
+          <a:lstStyle/>
+          <a:p>
+            <a:pPr algn="l">
+              <a:lnSpc>
+                <a:spcPct val="100000"/>
+              </a:lnSpc>
+            </a:pPr>
+            <a:r>
+              <a:rPr sz="1800" i="0" b="0">
+                <a:solidFill>
+                  <a:srgbClr val="33322E"/>
+                </a:solidFill>
+                <a:latin typeface="Cormorant Garamond"/>
+                <a:ea typeface="Cormorant Garamond"/>
+                <a:cs typeface="Cormorant Garamond"/>
+              </a:rPr>
+              <a:t>Maya Ellison</a:t>
+            </a:r>
+          </a:p>
+        </p:txBody>
+      </p:sp>
+      <p:sp>
+        <p:nvSpPr>
+          <p:cNvPr id="13" name="TextBox 12"/>
+          <p:cNvSpPr txBox="1"/>
+          <p:nvPr/>
+        </p:nvSpPr>
+        <p:spPr>
+          <a:xfrm>
+            <a:off x="1295400" y="1038225"/>
+            <a:ext cx="3282315" cy="123825"/>
+          </a:xfrm>
+          <a:prstGeom prst="rect">
+            <a:avLst/>
+          </a:prstGeom>
+          <a:noFill/>
+        </p:spPr>
+        <p:txBody>
+          <a:bodyPr wrap="none" anchor="t" lIns="0" rIns="0" tIns="0" bIns="0"/>
+          <a:lstStyle/>
+          <a:p>
+            <a:pPr algn="l"/>
+            <a:r>
+              <a:rPr sz="637" i="0" b="0" spc="216">
+                <a:solidFill>
+                  <a:srgbClr val="8A867E"/>
+                </a:solidFill>
+                <a:latin typeface="Poppins"/>
+                <a:ea typeface="Poppins"/>
+                <a:cs typeface="Poppins"/>
+              </a:rPr>
+              <a:t>REALTOR®  |  MODERN LIVING</a:t>
+            </a:r>
+          </a:p>
+        </p:txBody>
+      </p:sp>
+      <p:sp>
+        <p:nvSpPr>
+          <p:cNvPr id="14" name="TextBox 13"/>
+          <p:cNvSpPr txBox="1"/>
+          <p:nvPr/>
+        </p:nvSpPr>
+        <p:spPr>
+          <a:xfrm>
+            <a:off x="8257580" y="914400"/>
+            <a:ext cx="2408872" cy="95250"/>
+          </a:xfrm>
+          <a:prstGeom prst="rect">
+            <a:avLst/>
+          </a:prstGeom>
+          <a:noFill/>
+        </p:spPr>
+        <p:txBody>
+          <a:bodyPr wrap="none" anchor="t" lIns="0" rIns="0" tIns="0" bIns="0"/>
+          <a:lstStyle/>
+          <a:p>
+            <a:pPr algn="l">
+              <a:lnSpc>
+                <a:spcPct val="100000"/>
+              </a:lnSpc>
+            </a:pPr>
+            <a:r>
+              <a:rPr sz="750" i="0" b="0" spc="270">
+                <a:solidFill>
+                  <a:srgbClr val="97A98C"/>
+                </a:solidFill>
+                <a:latin typeface="Poppins"/>
+                <a:ea typeface="Poppins"/>
+                <a:cs typeface="Poppins"/>
+              </a:rPr>
+              <a:t>01 · JUST LISTED</a:t>
+            </a:r>
+          </a:p>
+        </p:txBody>
+      </p:sp>
+      <p:sp>
+        <p:nvSpPr>
+          <p:cNvPr id="15" name="TextBox 14"/>
+          <p:cNvSpPr txBox="1"/>
+          <p:nvPr/>
+        </p:nvSpPr>
+        <p:spPr>
+          <a:xfrm>
+            <a:off x="3940299" y="2116931"/>
+            <a:ext cx="2406253" cy="119062"/>
+          </a:xfrm>
+          <a:prstGeom prst="rect">
+            <a:avLst/>
+          </a:prstGeom>
+          <a:noFill/>
+        </p:spPr>
+        <p:txBody>
+          <a:bodyPr wrap="none" anchor="t" lIns="0" rIns="0" tIns="0" bIns="0"/>
+          <a:lstStyle/>
+          <a:p>
+            <a:pPr algn="ctr">
+              <a:lnSpc>
+                <a:spcPct val="100000"/>
+              </a:lnSpc>
+            </a:pPr>
+            <a:r>
+              <a:rPr sz="937" i="0" b="0" spc="412">
+                <a:solidFill>
+                  <a:srgbClr val="97A98C"/>
+                </a:solidFill>
+                <a:latin typeface="Poppins"/>
+                <a:ea typeface="Poppins"/>
+                <a:cs typeface="Poppins"/>
+              </a:rPr>
+              <a:t>JUST LISTED</a:t>
+            </a:r>
+          </a:p>
+        </p:txBody>
+      </p:sp>
+      <p:sp>
+        <p:nvSpPr>
+          <p:cNvPr id="16" name="TextBox 15"/>
+          <p:cNvSpPr txBox="1"/>
+          <p:nvPr/>
+        </p:nvSpPr>
+        <p:spPr>
+          <a:xfrm>
+            <a:off x="-2057400" y="2597944"/>
+            <a:ext cx="14401800" cy="2243138"/>
+          </a:xfrm>
+          <a:prstGeom prst="rect">
+            <a:avLst/>
+          </a:prstGeom>
+          <a:noFill/>
+        </p:spPr>
+        <p:txBody>
+          <a:bodyPr wrap="none" anchor="t" lIns="0" rIns="0" tIns="0" bIns="0"/>
+          <a:lstStyle/>
+          <a:p>
+            <a:pPr algn="ctr">
+              <a:lnSpc>
+                <a:spcPct val="92000"/>
+              </a:lnSpc>
+            </a:pPr>
+            <a:r>
+              <a:rPr sz="9600" i="1" b="0" spc="-48">
+                <a:solidFill>
+                  <a:srgbClr val="33322E"/>
+                </a:solidFill>
+                <a:latin typeface="Cormorant Garamond"/>
+                <a:ea typeface="Cormorant Garamond"/>
+                <a:cs typeface="Cormorant Garamond"/>
+              </a:rPr>
+              <a:t>New on</a:t>
+            </a:r>
+          </a:p>
+          <a:p>
+            <a:pPr algn="ctr">
+              <a:lnSpc>
+                <a:spcPct val="92000"/>
+              </a:lnSpc>
+            </a:pPr>
+            <a:r>
+              <a:rPr sz="9600" i="1" b="0" spc="-48">
+                <a:solidFill>
+                  <a:srgbClr val="33322E"/>
+                </a:solidFill>
+                <a:latin typeface="Cormorant Garamond"/>
+                <a:ea typeface="Cormorant Garamond"/>
+                <a:cs typeface="Cormorant Garamond"/>
+              </a:rPr>
+              <a:t>the Market</a:t>
+            </a:r>
+          </a:p>
+        </p:txBody>
+      </p:sp>
+      <p:sp>
+        <p:nvSpPr>
+          <p:cNvPr id="17" name="TextBox 16"/>
+          <p:cNvSpPr txBox="1"/>
+          <p:nvPr/>
+        </p:nvSpPr>
+        <p:spPr>
+          <a:xfrm>
+            <a:off x="-2057400" y="5145881"/>
+            <a:ext cx="14401800" cy="219075"/>
+          </a:xfrm>
+          <a:prstGeom prst="rect">
+            <a:avLst/>
+          </a:prstGeom>
+          <a:noFill/>
+        </p:spPr>
+        <p:txBody>
+          <a:bodyPr wrap="none" anchor="t" lIns="0" rIns="0" tIns="0" bIns="0"/>
+          <a:lstStyle/>
+          <a:p>
+            <a:pPr algn="ctr"/>
+            <a:r>
+              <a:rPr sz="1125" i="0" b="0" spc="225">
+                <a:solidFill>
+                  <a:srgbClr val="33322E"/>
+                </a:solidFill>
+                <a:latin typeface="Poppins"/>
+                <a:ea typeface="Poppins"/>
+                <a:cs typeface="Poppins"/>
+              </a:rPr>
+              <a:t>117 LARKSPUR LANE · AUSTIN, TX</a:t>
+            </a:r>
+          </a:p>
+        </p:txBody>
+      </p:sp>
+      <p:sp>
+        <p:nvSpPr>
+          <p:cNvPr id="18" name="TextBox 17"/>
+          <p:cNvSpPr txBox="1"/>
+          <p:nvPr/>
+        </p:nvSpPr>
+        <p:spPr>
+          <a:xfrm>
+            <a:off x="-2057400" y="5460206"/>
+            <a:ext cx="14401800" cy="419100"/>
+          </a:xfrm>
+          <a:prstGeom prst="rect">
+            <a:avLst/>
+          </a:prstGeom>
+          <a:noFill/>
+        </p:spPr>
+        <p:txBody>
+          <a:bodyPr wrap="none" anchor="t" lIns="0" rIns="0" tIns="0" bIns="0"/>
+          <a:lstStyle/>
+          <a:p>
+            <a:pPr algn="ctr"/>
+            <a:r>
+              <a:rPr sz="2850" i="0" b="0">
+                <a:solidFill>
+                  <a:srgbClr val="97A98C"/>
+                </a:solidFill>
+                <a:latin typeface="Cormorant Garamond"/>
+                <a:ea typeface="Cormorant Garamond"/>
+                <a:cs typeface="Cormorant Garamond"/>
+              </a:rPr>
+              <a:t>$740,000</a:t>
+            </a:r>
+          </a:p>
+        </p:txBody>
+      </p:sp>
+      <p:sp>
+        <p:nvSpPr>
+          <p:cNvPr id="19" name="TextBox 18"/>
+          <p:cNvSpPr txBox="1"/>
+          <p:nvPr/>
+        </p:nvSpPr>
+        <p:spPr>
+          <a:xfrm>
+            <a:off x="824895" y="6450806"/>
+            <a:ext cx="3804761" cy="504825"/>
+          </a:xfrm>
+          <a:prstGeom prst="rect">
+            <a:avLst/>
+          </a:prstGeom>
+          <a:noFill/>
+        </p:spPr>
+        <p:txBody>
+          <a:bodyPr wrap="none" anchor="t" lIns="0" rIns="0" tIns="0" bIns="0"/>
+          <a:lstStyle/>
+          <a:p>
+            <a:pPr algn="ctr"/>
+            <a:r>
+              <a:rPr sz="3450" i="0" b="0">
+                <a:solidFill>
+                  <a:srgbClr val="33322E"/>
+                </a:solidFill>
+                <a:latin typeface="Cormorant Garamond"/>
+                <a:ea typeface="Cormorant Garamond"/>
+                <a:cs typeface="Cormorant Garamond"/>
+              </a:rPr>
+              <a:t>4</a:t>
+            </a:r>
+          </a:p>
+        </p:txBody>
+      </p:sp>
+      <p:sp>
+        <p:nvSpPr>
+          <p:cNvPr id="20" name="TextBox 19"/>
+          <p:cNvSpPr txBox="1"/>
+          <p:nvPr/>
+        </p:nvSpPr>
+        <p:spPr>
+          <a:xfrm>
+            <a:off x="824895" y="7050881"/>
+            <a:ext cx="3804761" cy="152400"/>
+          </a:xfrm>
+          <a:prstGeom prst="rect">
+            <a:avLst/>
+          </a:prstGeom>
+          <a:noFill/>
+        </p:spPr>
+        <p:txBody>
+          <a:bodyPr wrap="none" anchor="t" lIns="0" rIns="0" tIns="0" bIns="0"/>
+          <a:lstStyle/>
+          <a:p>
+            <a:pPr algn="ctr"/>
+            <a:r>
+              <a:rPr sz="750" i="0" b="0" spc="225">
+                <a:solidFill>
+                  <a:srgbClr val="8A867E"/>
+                </a:solidFill>
+                <a:latin typeface="Poppins"/>
+                <a:ea typeface="Poppins"/>
+                <a:cs typeface="Poppins"/>
+              </a:rPr>
+              <a:t>BEDROOMS</a:t>
+            </a:r>
+          </a:p>
+        </p:txBody>
+      </p:sp>
+      <p:sp>
+        <p:nvSpPr>
+          <p:cNvPr id="21" name="TextBox 20"/>
+          <p:cNvSpPr txBox="1"/>
+          <p:nvPr/>
+        </p:nvSpPr>
+        <p:spPr>
+          <a:xfrm>
+            <a:off x="3240926" y="6450806"/>
+            <a:ext cx="3804999" cy="504825"/>
+          </a:xfrm>
+          <a:prstGeom prst="rect">
+            <a:avLst/>
+          </a:prstGeom>
+          <a:noFill/>
+        </p:spPr>
+        <p:txBody>
+          <a:bodyPr wrap="none" anchor="t" lIns="0" rIns="0" tIns="0" bIns="0"/>
+          <a:lstStyle/>
+          <a:p>
+            <a:pPr algn="ctr"/>
+            <a:r>
+              <a:rPr sz="3450" i="0" b="0">
+                <a:solidFill>
+                  <a:srgbClr val="33322E"/>
+                </a:solidFill>
+                <a:latin typeface="Cormorant Garamond"/>
+                <a:ea typeface="Cormorant Garamond"/>
+                <a:cs typeface="Cormorant Garamond"/>
+              </a:rPr>
+              <a:t>3</a:t>
+            </a:r>
+          </a:p>
+        </p:txBody>
+      </p:sp>
+      <p:sp>
+        <p:nvSpPr>
+          <p:cNvPr id="22" name="TextBox 21"/>
+          <p:cNvSpPr txBox="1"/>
+          <p:nvPr/>
+        </p:nvSpPr>
+        <p:spPr>
+          <a:xfrm>
+            <a:off x="3240926" y="7050881"/>
+            <a:ext cx="3804999" cy="152400"/>
+          </a:xfrm>
+          <a:prstGeom prst="rect">
+            <a:avLst/>
+          </a:prstGeom>
+          <a:noFill/>
+        </p:spPr>
+        <p:txBody>
+          <a:bodyPr wrap="none" anchor="t" lIns="0" rIns="0" tIns="0" bIns="0"/>
+          <a:lstStyle/>
+          <a:p>
+            <a:pPr algn="ctr"/>
+            <a:r>
+              <a:rPr sz="750" i="0" b="0" spc="225">
+                <a:solidFill>
+                  <a:srgbClr val="8A867E"/>
+                </a:solidFill>
+                <a:latin typeface="Poppins"/>
+                <a:ea typeface="Poppins"/>
+                <a:cs typeface="Poppins"/>
+              </a:rPr>
+              <a:t>BATHROOMS</a:t>
+            </a:r>
+          </a:p>
+        </p:txBody>
+      </p:sp>
+      <p:sp>
+        <p:nvSpPr>
+          <p:cNvPr id="23" name="TextBox 22"/>
+          <p:cNvSpPr txBox="1"/>
+          <p:nvPr/>
+        </p:nvSpPr>
+        <p:spPr>
+          <a:xfrm>
+            <a:off x="5657151" y="6450806"/>
+            <a:ext cx="3804999" cy="504825"/>
+          </a:xfrm>
+          <a:prstGeom prst="rect">
+            <a:avLst/>
+          </a:prstGeom>
+          <a:noFill/>
+        </p:spPr>
+        <p:txBody>
+          <a:bodyPr wrap="none" anchor="t" lIns="0" rIns="0" tIns="0" bIns="0"/>
+          <a:lstStyle/>
+          <a:p>
+            <a:pPr algn="ctr"/>
+            <a:r>
+              <a:rPr sz="3450" i="0" b="0">
+                <a:solidFill>
+                  <a:srgbClr val="33322E"/>
+                </a:solidFill>
+                <a:latin typeface="Cormorant Garamond"/>
+                <a:ea typeface="Cormorant Garamond"/>
+                <a:cs typeface="Cormorant Garamond"/>
+              </a:rPr>
+              <a:t>2,480</a:t>
+            </a:r>
+          </a:p>
+        </p:txBody>
+      </p:sp>
+      <p:sp>
+        <p:nvSpPr>
+          <p:cNvPr id="24" name="TextBox 23"/>
+          <p:cNvSpPr txBox="1"/>
+          <p:nvPr/>
+        </p:nvSpPr>
+        <p:spPr>
+          <a:xfrm>
+            <a:off x="5657151" y="7050881"/>
+            <a:ext cx="3804999" cy="152400"/>
+          </a:xfrm>
+          <a:prstGeom prst="rect">
+            <a:avLst/>
+          </a:prstGeom>
+          <a:noFill/>
+        </p:spPr>
+        <p:txBody>
+          <a:bodyPr wrap="none" anchor="t" lIns="0" rIns="0" tIns="0" bIns="0"/>
+          <a:lstStyle/>
+          <a:p>
+            <a:pPr algn="ctr"/>
+            <a:r>
+              <a:rPr sz="750" i="0" b="0" spc="225">
+                <a:solidFill>
+                  <a:srgbClr val="8A867E"/>
+                </a:solidFill>
+                <a:latin typeface="Poppins"/>
+                <a:ea typeface="Poppins"/>
+                <a:cs typeface="Poppins"/>
+              </a:rPr>
+              <a:t>SQ FT</a:t>
+            </a:r>
+          </a:p>
+        </p:txBody>
+      </p:sp>
+      <p:sp>
+        <p:nvSpPr>
+          <p:cNvPr id="25" name="TextBox 24"/>
+          <p:cNvSpPr txBox="1"/>
+          <p:nvPr/>
+        </p:nvSpPr>
+        <p:spPr>
+          <a:xfrm>
+            <a:off x="942975" y="9372600"/>
+            <a:ext cx="4217432" cy="152400"/>
+          </a:xfrm>
+          <a:prstGeom prst="rect">
+            <a:avLst/>
+          </a:prstGeom>
+          <a:noFill/>
+        </p:spPr>
+        <p:txBody>
+          <a:bodyPr wrap="none" anchor="t" lIns="0" rIns="0" tIns="0" bIns="0"/>
+          <a:lstStyle/>
+          <a:p>
+            <a:pPr algn="l"/>
+            <a:r>
+              <a:rPr sz="750" i="0" b="0" spc="195">
+                <a:solidFill>
+                  <a:srgbClr val="8A867E"/>
+                </a:solidFill>
+                <a:latin typeface="Poppins"/>
+                <a:ea typeface="Poppins"/>
+                <a:cs typeface="Poppins"/>
+              </a:rPr>
+              <a:t>@MAYAELLISON · MAYAELLISON.COM</a:t>
+            </a:r>
+          </a:p>
+        </p:txBody>
+      </p:sp>
+      <p:sp>
+        <p:nvSpPr>
+          <p:cNvPr id="26" name="TextBox 25"/>
+          <p:cNvSpPr txBox="1"/>
+          <p:nvPr/>
+        </p:nvSpPr>
+        <p:spPr>
+          <a:xfrm>
+            <a:off x="8430667" y="9372600"/>
+            <a:ext cx="2131933" cy="152400"/>
+          </a:xfrm>
+          <a:prstGeom prst="rect">
+            <a:avLst/>
+          </a:prstGeom>
+          <a:noFill/>
+        </p:spPr>
+        <p:txBody>
+          <a:bodyPr wrap="none" anchor="t" lIns="0" rIns="0" tIns="0" bIns="0"/>
+          <a:lstStyle/>
+          <a:p>
+            <a:pPr algn="l"/>
+            <a:r>
+              <a:rPr sz="750" i="0" b="0" spc="195">
+                <a:solidFill>
+                  <a:srgbClr val="97A98C"/>
+                </a:solidFill>
+                <a:latin typeface="Poppins"/>
+                <a:ea typeface="Poppins"/>
+                <a:cs typeface="Poppins"/>
+              </a:rPr>
+              <a:t>DM FOR DETAILS</a:t>
+            </a:r>
+          </a:p>
+        </p:txBody>
+      </p:sp>
     </p:spTree>
   </p:cSld>
   <p:clrMapOvr>

</xml_diff>